<commit_message>
fix: remove lifetime earned bug, clean up repo for public release
- Replace buggy Lifetime Earned with Salary Rate display
- Immediate refresh on milestone payment (no 2s delay)
- Remove redundant screenshot images
- Exclude claude prompts, orchestrator, and docs from public repo
- Update .gitignore for clean public GitHub presence
- Remove 60fps badge from presentation
</commit_message>
<xml_diff>
--- a/AlgoFlow_Presentation.pptx
+++ b/AlgoFlow_Presentation.pptx
@@ -3591,7 +3591,7 @@
         <p:spPr>
           <a:xfrm>
             <a:off x="7315200" y="4663440"/>
-            <a:ext cx="1737360" cy="274320"/>
+            <a:ext cx="1186180" cy="274320"/>
           </a:xfrm>
           <a:prstGeom prst="roundRect">
             <a:avLst/>
@@ -3630,7 +3630,7 @@
               </a:defRPr>
             </a:pPr>
             <a:r>
-              <a:t>60fps Streaming UI</a:t>
+              <a:t>Pera Wallet</a:t>
             </a:r>
           </a:p>
         </p:txBody>

</xml_diff>